<commit_message>
Bài giảng điện tử Toán 10 Bài 7–10, Toán 12 Bài 6–8, BTCC II: sửa thứ tự xuất hiện theo click
Mỗi slide chỉ hiện sẵn đề đầu tiên; lời giải, ví dụ/luyện tập kế tiếp, khung kiến thức hiện lần lượt theo click.

Co-Authored-By: Claude Opus 5.5 <noreply@anthropic.com>
</commit_message>
<xml_diff>
--- a/mon/toan/slide/lop10/BaiGiangDienTu_TOAN10_Bai7_CacKhaiNiemMoDau_T26-27.pptx
+++ b/mon/toan/slide/lop10/BaiGiangDienTu_TOAN10_Bai7_CacKhaiNiemMoDau_T26-27.pptx
@@ -7661,7 +7661,7 @@
       </mc:AlternateContent>
       <p:sp>
         <p:nvSpPr>
-          <p:cNvPr id="10" name="Rounded Rectangle 9"/>
+          <p:cNvPr id="10" name="s2_nen"/>
           <p:cNvSpPr/>
           <p:nvPr/>
         </p:nvSpPr>
@@ -7709,7 +7709,7 @@
       </p:sp>
       <p:sp>
         <p:nvSpPr>
-          <p:cNvPr id="11" name="TextBox 10"/>
+          <p:cNvPr id="11" name="s2_chu"/>
           <p:cNvSpPr txBox="1"/>
           <p:nvPr/>
         </p:nvSpPr>
@@ -7784,7 +7784,7 @@
       </p:sp>
       <p:sp>
         <p:nvSpPr>
-          <p:cNvPr id="12" name="TextBox 11"/>
+          <p:cNvPr id="12" name="s3_chu"/>
           <p:cNvSpPr txBox="1"/>
           <p:nvPr/>
         </p:nvSpPr>
@@ -7912,6 +7912,123 @@
                                         </p:cTn>
                                         <p:tgtEl>
                                           <p:spTgt spid="9"/>
+                                        </p:tgtEl>
+                                        <p:attrNameLst>
+                                          <p:attrName>style.visibility</p:attrName>
+                                        </p:attrNameLst>
+                                      </p:cBhvr>
+                                      <p:to>
+                                        <p:strVal val="visible"/>
+                                      </p:to>
+                                    </p:set>
+                                  </p:childTnLst>
+                                </p:cTn>
+                              </p:par>
+                            </p:childTnLst>
+                          </p:cTn>
+                        </p:par>
+                      </p:childTnLst>
+                    </p:cTn>
+                  </p:par>
+                  <p:par>
+                    <p:cTn id="9" fill="hold">
+                      <p:stCondLst>
+                        <p:cond delay="indefinite"/>
+                      </p:stCondLst>
+                      <p:childTnLst>
+                        <p:par>
+                          <p:cTn id="10" fill="hold">
+                            <p:stCondLst>
+                              <p:cond delay="0"/>
+                            </p:stCondLst>
+                            <p:childTnLst>
+                              <p:par>
+                                <p:cTn id="11" presetID="1" presetClass="entr" presetSubtype="0" fill="hold" nodeType="clickEffect">
+                                  <p:stCondLst>
+                                    <p:cond delay="0"/>
+                                  </p:stCondLst>
+                                  <p:childTnLst>
+                                    <p:set>
+                                      <p:cBhvr>
+                                        <p:cTn id="12" dur="1" fill="hold">
+                                          <p:stCondLst>
+                                            <p:cond delay="0"/>
+                                          </p:stCondLst>
+                                        </p:cTn>
+                                        <p:tgtEl>
+                                          <p:spTgt spid="10"/>
+                                        </p:tgtEl>
+                                        <p:attrNameLst>
+                                          <p:attrName>style.visibility</p:attrName>
+                                        </p:attrNameLst>
+                                      </p:cBhvr>
+                                      <p:to>
+                                        <p:strVal val="visible"/>
+                                      </p:to>
+                                    </p:set>
+                                  </p:childTnLst>
+                                </p:cTn>
+                              </p:par>
+                              <p:par>
+                                <p:cTn id="13" presetID="1" presetClass="entr" presetSubtype="0" fill="hold" nodeType="withEffect">
+                                  <p:stCondLst>
+                                    <p:cond delay="0"/>
+                                  </p:stCondLst>
+                                  <p:childTnLst>
+                                    <p:set>
+                                      <p:cBhvr>
+                                        <p:cTn id="14" dur="1" fill="hold">
+                                          <p:stCondLst>
+                                            <p:cond delay="0"/>
+                                          </p:stCondLst>
+                                        </p:cTn>
+                                        <p:tgtEl>
+                                          <p:spTgt spid="11"/>
+                                        </p:tgtEl>
+                                        <p:attrNameLst>
+                                          <p:attrName>style.visibility</p:attrName>
+                                        </p:attrNameLst>
+                                      </p:cBhvr>
+                                      <p:to>
+                                        <p:strVal val="visible"/>
+                                      </p:to>
+                                    </p:set>
+                                  </p:childTnLst>
+                                </p:cTn>
+                              </p:par>
+                            </p:childTnLst>
+                          </p:cTn>
+                        </p:par>
+                      </p:childTnLst>
+                    </p:cTn>
+                  </p:par>
+                  <p:par>
+                    <p:cTn id="15" fill="hold">
+                      <p:stCondLst>
+                        <p:cond delay="indefinite"/>
+                      </p:stCondLst>
+                      <p:childTnLst>
+                        <p:par>
+                          <p:cTn id="16" fill="hold">
+                            <p:stCondLst>
+                              <p:cond delay="0"/>
+                            </p:stCondLst>
+                            <p:childTnLst>
+                              <p:par>
+                                <p:cTn id="17" presetID="1" presetClass="entr" presetSubtype="0" fill="hold" nodeType="clickEffect">
+                                  <p:stCondLst>
+                                    <p:cond delay="0"/>
+                                  </p:stCondLst>
+                                  <p:childTnLst>
+                                    <p:set>
+                                      <p:cBhvr>
+                                        <p:cTn id="18" dur="1" fill="hold">
+                                          <p:stCondLst>
+                                            <p:cond delay="0"/>
+                                          </p:stCondLst>
+                                        </p:cTn>
+                                        <p:tgtEl>
+                                          <p:spTgt spid="12"/>
                                         </p:tgtEl>
                                         <p:attrNameLst>
                                           <p:attrName>style.visibility</p:attrName>
@@ -18559,7 +18676,7 @@
       </mc:AlternateContent>
       <p:sp>
         <p:nvSpPr>
-          <p:cNvPr id="12" name="Rounded Rectangle 11"/>
+          <p:cNvPr id="12" name="s3_nen"/>
           <p:cNvSpPr/>
           <p:nvPr/>
         </p:nvSpPr>
@@ -18609,7 +18726,7 @@
         <mc:Choice xmlns:a14="http://schemas.microsoft.com/office/drawing/2010/main" Requires="a14">
           <p:sp>
             <p:nvSpPr>
-              <p:cNvPr id="13" name="TextBox 12"/>
+              <p:cNvPr id="13" name="s3_chu"/>
               <p:cNvSpPr txBox="1"/>
               <p:nvPr/>
             </p:nvSpPr>
@@ -19025,6 +19142,78 @@
                       </p:childTnLst>
                     </p:cTn>
                   </p:par>
+                  <p:par>
+                    <p:cTn id="15" fill="hold">
+                      <p:stCondLst>
+                        <p:cond delay="indefinite"/>
+                      </p:stCondLst>
+                      <p:childTnLst>
+                        <p:par>
+                          <p:cTn id="16" fill="hold">
+                            <p:stCondLst>
+                              <p:cond delay="0"/>
+                            </p:stCondLst>
+                            <p:childTnLst>
+                              <p:par>
+                                <p:cTn id="17" presetID="1" presetClass="entr" presetSubtype="0" fill="hold" nodeType="clickEffect">
+                                  <p:stCondLst>
+                                    <p:cond delay="0"/>
+                                  </p:stCondLst>
+                                  <p:childTnLst>
+                                    <p:set>
+                                      <p:cBhvr>
+                                        <p:cTn id="18" dur="1" fill="hold">
+                                          <p:stCondLst>
+                                            <p:cond delay="0"/>
+                                          </p:stCondLst>
+                                        </p:cTn>
+                                        <p:tgtEl>
+                                          <p:spTgt spid="12"/>
+                                        </p:tgtEl>
+                                        <p:attrNameLst>
+                                          <p:attrName>style.visibility</p:attrName>
+                                        </p:attrNameLst>
+                                      </p:cBhvr>
+                                      <p:to>
+                                        <p:strVal val="visible"/>
+                                      </p:to>
+                                    </p:set>
+                                  </p:childTnLst>
+                                </p:cTn>
+                              </p:par>
+                              <p:par>
+                                <p:cTn id="19" presetID="1" presetClass="entr" presetSubtype="0" fill="hold" nodeType="withEffect">
+                                  <p:stCondLst>
+                                    <p:cond delay="0"/>
+                                  </p:stCondLst>
+                                  <p:childTnLst>
+                                    <p:set>
+                                      <p:cBhvr>
+                                        <p:cTn id="20" dur="1" fill="hold">
+                                          <p:stCondLst>
+                                            <p:cond delay="0"/>
+                                          </p:stCondLst>
+                                        </p:cTn>
+                                        <p:tgtEl>
+                                          <p:spTgt spid="13"/>
+                                        </p:tgtEl>
+                                        <p:attrNameLst>
+                                          <p:attrName>style.visibility</p:attrName>
+                                        </p:attrNameLst>
+                                      </p:cBhvr>
+                                      <p:to>
+                                        <p:strVal val="visible"/>
+                                      </p:to>
+                                    </p:set>
+                                  </p:childTnLst>
+                                </p:cTn>
+                              </p:par>
+                            </p:childTnLst>
+                          </p:cTn>
+                        </p:par>
+                      </p:childTnLst>
+                    </p:cTn>
+                  </p:par>
                 </p:childTnLst>
               </p:cTn>
               <p:prevCondLst>
@@ -20385,7 +20574,7 @@
         <mc:Choice xmlns:a14="http://schemas.microsoft.com/office/drawing/2010/main" Requires="a14">
           <p:sp>
             <p:nvSpPr>
-              <p:cNvPr id="8" name="TextBox 7"/>
+              <p:cNvPr id="8" name="s1_chu"/>
               <p:cNvSpPr txBox="1"/>
               <p:nvPr/>
             </p:nvSpPr>
@@ -20899,7 +21088,7 @@
       </mc:AlternateContent>
       <p:sp>
         <p:nvSpPr>
-          <p:cNvPr id="9" name="s1_nen"/>
+          <p:cNvPr id="9" name="s2_nen"/>
           <p:cNvSpPr/>
           <p:nvPr/>
         </p:nvSpPr>
@@ -20949,7 +21138,7 @@
         <mc:Choice xmlns:a14="http://schemas.microsoft.com/office/drawing/2010/main" Requires="a14">
           <p:sp>
             <p:nvSpPr>
-              <p:cNvPr id="10" name="s1_chu"/>
+              <p:cNvPr id="10" name="s2_chu"/>
               <p:cNvSpPr txBox="1"/>
               <p:nvPr/>
             </p:nvSpPr>
@@ -21261,6 +21450,51 @@
                                           </p:stCondLst>
                                         </p:cTn>
                                         <p:tgtEl>
+                                          <p:spTgt spid="8"/>
+                                        </p:tgtEl>
+                                        <p:attrNameLst>
+                                          <p:attrName>style.visibility</p:attrName>
+                                        </p:attrNameLst>
+                                      </p:cBhvr>
+                                      <p:to>
+                                        <p:strVal val="visible"/>
+                                      </p:to>
+                                    </p:set>
+                                  </p:childTnLst>
+                                </p:cTn>
+                              </p:par>
+                            </p:childTnLst>
+                          </p:cTn>
+                        </p:par>
+                      </p:childTnLst>
+                    </p:cTn>
+                  </p:par>
+                  <p:par>
+                    <p:cTn id="7" fill="hold">
+                      <p:stCondLst>
+                        <p:cond delay="indefinite"/>
+                      </p:stCondLst>
+                      <p:childTnLst>
+                        <p:par>
+                          <p:cTn id="8" fill="hold">
+                            <p:stCondLst>
+                              <p:cond delay="0"/>
+                            </p:stCondLst>
+                            <p:childTnLst>
+                              <p:par>
+                                <p:cTn id="9" presetID="1" presetClass="entr" presetSubtype="0" fill="hold" nodeType="clickEffect">
+                                  <p:stCondLst>
+                                    <p:cond delay="0"/>
+                                  </p:stCondLst>
+                                  <p:childTnLst>
+                                    <p:set>
+                                      <p:cBhvr>
+                                        <p:cTn id="10" dur="1" fill="hold">
+                                          <p:stCondLst>
+                                            <p:cond delay="0"/>
+                                          </p:stCondLst>
+                                        </p:cTn>
+                                        <p:tgtEl>
                                           <p:spTgt spid="9"/>
                                         </p:tgtEl>
                                         <p:attrNameLst>
@@ -21275,14 +21509,14 @@
                                 </p:cTn>
                               </p:par>
                               <p:par>
-                                <p:cTn id="7" presetID="1" presetClass="entr" presetSubtype="0" fill="hold" nodeType="withEffect">
+                                <p:cTn id="11" presetID="1" presetClass="entr" presetSubtype="0" fill="hold" nodeType="withEffect">
                                   <p:stCondLst>
                                     <p:cond delay="0"/>
                                   </p:stCondLst>
                                   <p:childTnLst>
                                     <p:set>
                                       <p:cBhvr>
-                                        <p:cTn id="8" dur="1" fill="hold">
+                                        <p:cTn id="12" dur="1" fill="hold">
                                           <p:stCondLst>
                                             <p:cond delay="0"/>
                                           </p:stCondLst>
@@ -23519,7 +23753,7 @@
         <mc:Choice xmlns:a14="http://schemas.microsoft.com/office/drawing/2010/main" Requires="a14">
           <p:sp>
             <p:nvSpPr>
-              <p:cNvPr id="8" name="TextBox 7"/>
+              <p:cNvPr id="8" name="s1_chu"/>
               <p:cNvSpPr txBox="1"/>
               <p:nvPr/>
             </p:nvSpPr>
@@ -23986,7 +24220,7 @@
       </mc:AlternateContent>
       <p:sp>
         <p:nvSpPr>
-          <p:cNvPr id="9" name="s1_nen"/>
+          <p:cNvPr id="9" name="s2_nen"/>
           <p:cNvSpPr/>
           <p:nvPr/>
         </p:nvSpPr>
@@ -24036,7 +24270,7 @@
         <mc:Choice xmlns:a14="http://schemas.microsoft.com/office/drawing/2010/main" Requires="a14">
           <p:sp>
             <p:nvSpPr>
-              <p:cNvPr id="10" name="s1_chu"/>
+              <p:cNvPr id="10" name="s2_chu"/>
               <p:cNvSpPr txBox="1"/>
               <p:nvPr/>
             </p:nvSpPr>
@@ -24457,7 +24691,7 @@
       </mc:AlternateContent>
       <p:sp>
         <p:nvSpPr>
-          <p:cNvPr id="11" name="s2_nen"/>
+          <p:cNvPr id="11" name="s3_nen"/>
           <p:cNvSpPr/>
           <p:nvPr/>
         </p:nvSpPr>
@@ -24507,7 +24741,7 @@
         <mc:Choice xmlns:a14="http://schemas.microsoft.com/office/drawing/2010/main" Requires="a14">
           <p:sp>
             <p:nvSpPr>
-              <p:cNvPr id="12" name="s2_chu"/>
+              <p:cNvPr id="12" name="s3_chu"/>
               <p:cNvSpPr txBox="1"/>
               <p:nvPr/>
             </p:nvSpPr>
@@ -25151,6 +25385,51 @@
                                           </p:stCondLst>
                                         </p:cTn>
                                         <p:tgtEl>
+                                          <p:spTgt spid="8"/>
+                                        </p:tgtEl>
+                                        <p:attrNameLst>
+                                          <p:attrName>style.visibility</p:attrName>
+                                        </p:attrNameLst>
+                                      </p:cBhvr>
+                                      <p:to>
+                                        <p:strVal val="visible"/>
+                                      </p:to>
+                                    </p:set>
+                                  </p:childTnLst>
+                                </p:cTn>
+                              </p:par>
+                            </p:childTnLst>
+                          </p:cTn>
+                        </p:par>
+                      </p:childTnLst>
+                    </p:cTn>
+                  </p:par>
+                  <p:par>
+                    <p:cTn id="7" fill="hold">
+                      <p:stCondLst>
+                        <p:cond delay="indefinite"/>
+                      </p:stCondLst>
+                      <p:childTnLst>
+                        <p:par>
+                          <p:cTn id="8" fill="hold">
+                            <p:stCondLst>
+                              <p:cond delay="0"/>
+                            </p:stCondLst>
+                            <p:childTnLst>
+                              <p:par>
+                                <p:cTn id="9" presetID="1" presetClass="entr" presetSubtype="0" fill="hold" nodeType="clickEffect">
+                                  <p:stCondLst>
+                                    <p:cond delay="0"/>
+                                  </p:stCondLst>
+                                  <p:childTnLst>
+                                    <p:set>
+                                      <p:cBhvr>
+                                        <p:cTn id="10" dur="1" fill="hold">
+                                          <p:stCondLst>
+                                            <p:cond delay="0"/>
+                                          </p:stCondLst>
+                                        </p:cTn>
+                                        <p:tgtEl>
                                           <p:spTgt spid="9"/>
                                         </p:tgtEl>
                                         <p:attrNameLst>
@@ -25165,14 +25444,14 @@
                                 </p:cTn>
                               </p:par>
                               <p:par>
-                                <p:cTn id="7" presetID="1" presetClass="entr" presetSubtype="0" fill="hold" nodeType="withEffect">
+                                <p:cTn id="11" presetID="1" presetClass="entr" presetSubtype="0" fill="hold" nodeType="withEffect">
                                   <p:stCondLst>
                                     <p:cond delay="0"/>
                                   </p:stCondLst>
                                   <p:childTnLst>
                                     <p:set>
                                       <p:cBhvr>
-                                        <p:cTn id="8" dur="1" fill="hold">
+                                        <p:cTn id="12" dur="1" fill="hold">
                                           <p:stCondLst>
                                             <p:cond delay="0"/>
                                           </p:stCondLst>
@@ -25198,26 +25477,26 @@
                     </p:cTn>
                   </p:par>
                   <p:par>
-                    <p:cTn id="9" fill="hold">
+                    <p:cTn id="13" fill="hold">
                       <p:stCondLst>
                         <p:cond delay="indefinite"/>
                       </p:stCondLst>
                       <p:childTnLst>
                         <p:par>
-                          <p:cTn id="10" fill="hold">
+                          <p:cTn id="14" fill="hold">
                             <p:stCondLst>
                               <p:cond delay="0"/>
                             </p:stCondLst>
                             <p:childTnLst>
                               <p:par>
-                                <p:cTn id="11" presetID="1" presetClass="entr" presetSubtype="0" fill="hold" nodeType="clickEffect">
+                                <p:cTn id="15" presetID="1" presetClass="entr" presetSubtype="0" fill="hold" nodeType="clickEffect">
                                   <p:stCondLst>
                                     <p:cond delay="0"/>
                                   </p:stCondLst>
                                   <p:childTnLst>
                                     <p:set>
                                       <p:cBhvr>
-                                        <p:cTn id="12" dur="1" fill="hold">
+                                        <p:cTn id="16" dur="1" fill="hold">
                                           <p:stCondLst>
                                             <p:cond delay="0"/>
                                           </p:stCondLst>
@@ -25237,14 +25516,14 @@
                                 </p:cTn>
                               </p:par>
                               <p:par>
-                                <p:cTn id="13" presetID="1" presetClass="entr" presetSubtype="0" fill="hold" nodeType="withEffect">
+                                <p:cTn id="17" presetID="1" presetClass="entr" presetSubtype="0" fill="hold" nodeType="withEffect">
                                   <p:stCondLst>
                                     <p:cond delay="0"/>
                                   </p:stCondLst>
                                   <p:childTnLst>
                                     <p:set>
                                       <p:cBhvr>
-                                        <p:cTn id="14" dur="1" fill="hold">
+                                        <p:cTn id="18" dur="1" fill="hold">
                                           <p:stCondLst>
                                             <p:cond delay="0"/>
                                           </p:stCondLst>
@@ -25533,7 +25812,7 @@
             <p:spPr>
               <a:xfrm>
                 <a:off x="548640" y="1371600"/>
-                <a:ext cx="8138160" cy="2301240"/>
+                <a:ext cx="8138160" cy="1621536"/>
               </a:xfrm>
               <a:prstGeom prst="rect">
                 <a:avLst/>
@@ -26272,31 +26551,6 @@
                   <a:t> cùng hướng.</a:t>
                 </a:r>
               </a:p>
-              <a:p>
-                <a:pPr algn="l">
-                  <a:spcAft>
-                    <a:spcPts val="800"/>
-                  </a:spcAft>
-                </a:pPr>
-                <a:r>
-                  <a:rPr sz="1900" b="1">
-                    <a:solidFill>
-                      <a:srgbClr val="1E293B"/>
-                    </a:solidFill>
-                    <a:latin typeface="Calibri"/>
-                  </a:rPr>
-                  <a:t>4.2.</a:t>
-                </a:r>
-                <a:r>
-                  <a:rPr sz="1900">
-                    <a:solidFill>
-                      <a:srgbClr val="1E293B"/>
-                    </a:solidFill>
-                    <a:latin typeface="Calibri"/>
-                  </a:rPr>
-                  <a:t> Trong Hình 4.12, chỉ ra các vectơ cùng phương, các cặp vectơ ngược hướng và các cặp vectơ bằng nhau.</a:t>
-                </a:r>
-              </a:p>
             </p:txBody>
           </p:sp>
         </mc:Choice>
@@ -26310,7 +26564,7 @@
             <p:spPr>
               <a:xfrm>
                 <a:off x="548640" y="1371600"/>
-                <a:ext cx="8138160" cy="2301240"/>
+                <a:ext cx="8138160" cy="1621536"/>
               </a:xfrm>
               <a:prstGeom prst="rect">
                 <a:avLst/>
@@ -26529,31 +26783,6 @@
                   <a:t> cùng hướng.</a:t>
                 </a:r>
               </a:p>
-              <a:p>
-                <a:pPr algn="l">
-                  <a:spcAft>
-                    <a:spcPts val="800"/>
-                  </a:spcAft>
-                </a:pPr>
-                <a:r>
-                  <a:rPr sz="1900" b="1">
-                    <a:solidFill>
-                      <a:srgbClr val="1E293B"/>
-                    </a:solidFill>
-                    <a:latin typeface="Calibri"/>
-                  </a:rPr>
-                  <a:t>4.2.</a:t>
-                </a:r>
-                <a:r>
-                  <a:rPr sz="1900">
-                    <a:solidFill>
-                      <a:srgbClr val="1E293B"/>
-                    </a:solidFill>
-                    <a:latin typeface="Calibri"/>
-                  </a:rPr>
-                  <a:t> Trong Hình 4.12, chỉ ra các vectơ cùng phương, các cặp vectơ ngược hướng và các cặp vectơ bằng nhau.</a:t>
-                </a:r>
-              </a:p>
             </p:txBody>
           </p:sp>
         </mc:Fallback>
@@ -26566,7 +26795,7 @@
         </p:nvSpPr>
         <p:spPr>
           <a:xfrm>
-            <a:off x="548640" y="3764280"/>
+            <a:off x="548640" y="3057144"/>
             <a:ext cx="8138160" cy="844295"/>
           </a:xfrm>
           <a:prstGeom prst="roundRect">
@@ -26616,7 +26845,7 @@
             </p:nvSpPr>
             <p:spPr>
               <a:xfrm>
-                <a:off x="713232" y="3800856"/>
+                <a:off x="713232" y="3093720"/>
                 <a:ext cx="7808976" cy="771143"/>
               </a:xfrm>
               <a:prstGeom prst="rect">
@@ -26724,7 +26953,7 @@
             </p:nvSpPr>
             <p:spPr>
               <a:xfrm>
-                <a:off x="713232" y="3800856"/>
+                <a:off x="713232" y="3093720"/>
                 <a:ext cx="7808976" cy="771143"/>
               </a:xfrm>
               <a:prstGeom prst="rect">
@@ -26794,13 +27023,61 @@
       </mc:AlternateContent>
       <p:sp>
         <p:nvSpPr>
-          <p:cNvPr id="10" name="s2_nen"/>
+          <p:cNvPr id="10" name="s2_chu"/>
+          <p:cNvSpPr txBox="1"/>
+          <p:nvPr/>
+        </p:nvSpPr>
+        <p:spPr>
+          <a:xfrm>
+            <a:off x="548640" y="3965448"/>
+            <a:ext cx="8138160" cy="752855"/>
+          </a:xfrm>
+          <a:prstGeom prst="rect">
+            <a:avLst/>
+          </a:prstGeom>
+          <a:noFill/>
+        </p:spPr>
+        <p:txBody>
+          <a:bodyPr wrap="square" anchor="t" lIns="45720" rIns="45720">
+            <a:spAutoFit/>
+          </a:bodyPr>
+          <a:lstStyle/>
+          <a:p>
+            <a:pPr algn="l">
+              <a:spcAft>
+                <a:spcPts val="800"/>
+              </a:spcAft>
+            </a:pPr>
+            <a:r>
+              <a:rPr sz="1900" b="1">
+                <a:solidFill>
+                  <a:srgbClr val="1E293B"/>
+                </a:solidFill>
+                <a:latin typeface="Calibri"/>
+              </a:rPr>
+              <a:t>4.2.</a:t>
+            </a:r>
+            <a:r>
+              <a:rPr sz="1900">
+                <a:solidFill>
+                  <a:srgbClr val="1E293B"/>
+                </a:solidFill>
+                <a:latin typeface="Calibri"/>
+              </a:rPr>
+              <a:t> Trong Hình 4.12, chỉ ra các vectơ cùng phương, các cặp vectơ ngược hướng và các cặp vectơ bằng nhau.</a:t>
+            </a:r>
+          </a:p>
+        </p:txBody>
+      </p:sp>
+      <p:sp>
+        <p:nvSpPr>
+          <p:cNvPr id="11" name="s3_nen"/>
           <p:cNvSpPr/>
           <p:nvPr/>
         </p:nvSpPr>
         <p:spPr>
           <a:xfrm>
-            <a:off x="548640" y="4663440"/>
+            <a:off x="548640" y="4782312"/>
             <a:ext cx="8138160" cy="844295"/>
           </a:xfrm>
           <a:prstGeom prst="roundRect">
@@ -26844,13 +27121,13 @@
         <mc:Choice xmlns:a14="http://schemas.microsoft.com/office/drawing/2010/main" Requires="a14">
           <p:sp>
             <p:nvSpPr>
-              <p:cNvPr id="11" name="s2_chu"/>
+              <p:cNvPr id="12" name="s3_chu"/>
               <p:cNvSpPr txBox="1"/>
               <p:nvPr/>
             </p:nvSpPr>
             <p:spPr>
               <a:xfrm>
-                <a:off x="713232" y="4700016"/>
+                <a:off x="713232" y="4818888"/>
                 <a:ext cx="7808976" cy="771143"/>
               </a:xfrm>
               <a:prstGeom prst="rect">
@@ -27238,13 +27515,13 @@
         <mc:Fallback>
           <p:sp>
             <p:nvSpPr>
-              <p:cNvPr id="11" name="TextBox 10"/>
+              <p:cNvPr id="12" name="TextBox 11"/>
               <p:cNvSpPr txBox="1"/>
               <p:nvPr/>
             </p:nvSpPr>
             <p:spPr>
               <a:xfrm>
-                <a:off x="713232" y="4700016"/>
+                <a:off x="713232" y="4818888"/>
                 <a:ext cx="7808976" cy="771143"/>
               </a:xfrm>
               <a:prstGeom prst="rect">
@@ -27431,7 +27708,7 @@
       </mc:AlternateContent>
       <p:pic>
         <p:nvPicPr>
-          <p:cNvPr id="12" name="Picture 11" descr="h412.png"/>
+          <p:cNvPr id="13" name="Picture 12" descr="h412.png"/>
           <p:cNvPicPr>
             <a:picLocks noChangeAspect="1"/>
           </p:cNvPicPr>
@@ -27577,21 +27854,66 @@
                                   </p:childTnLst>
                                 </p:cTn>
                               </p:par>
+                            </p:childTnLst>
+                          </p:cTn>
+                        </p:par>
+                      </p:childTnLst>
+                    </p:cTn>
+                  </p:par>
+                  <p:par>
+                    <p:cTn id="13" fill="hold">
+                      <p:stCondLst>
+                        <p:cond delay="indefinite"/>
+                      </p:stCondLst>
+                      <p:childTnLst>
+                        <p:par>
+                          <p:cTn id="14" fill="hold">
+                            <p:stCondLst>
+                              <p:cond delay="0"/>
+                            </p:stCondLst>
+                            <p:childTnLst>
                               <p:par>
-                                <p:cTn id="13" presetID="1" presetClass="entr" presetSubtype="0" fill="hold" nodeType="withEffect">
+                                <p:cTn id="15" presetID="1" presetClass="entr" presetSubtype="0" fill="hold" nodeType="clickEffect">
                                   <p:stCondLst>
                                     <p:cond delay="0"/>
                                   </p:stCondLst>
                                   <p:childTnLst>
                                     <p:set>
                                       <p:cBhvr>
-                                        <p:cTn id="14" dur="1" fill="hold">
+                                        <p:cTn id="16" dur="1" fill="hold">
                                           <p:stCondLst>
                                             <p:cond delay="0"/>
                                           </p:stCondLst>
                                         </p:cTn>
                                         <p:tgtEl>
                                           <p:spTgt spid="11"/>
+                                        </p:tgtEl>
+                                        <p:attrNameLst>
+                                          <p:attrName>style.visibility</p:attrName>
+                                        </p:attrNameLst>
+                                      </p:cBhvr>
+                                      <p:to>
+                                        <p:strVal val="visible"/>
+                                      </p:to>
+                                    </p:set>
+                                  </p:childTnLst>
+                                </p:cTn>
+                              </p:par>
+                              <p:par>
+                                <p:cTn id="17" presetID="1" presetClass="entr" presetSubtype="0" fill="hold" nodeType="withEffect">
+                                  <p:stCondLst>
+                                    <p:cond delay="0"/>
+                                  </p:stCondLst>
+                                  <p:childTnLst>
+                                    <p:set>
+                                      <p:cBhvr>
+                                        <p:cTn id="18" dur="1" fill="hold">
+                                          <p:stCondLst>
+                                            <p:cond delay="0"/>
+                                          </p:stCondLst>
+                                        </p:cTn>
+                                        <p:tgtEl>
+                                          <p:spTgt spid="12"/>
                                         </p:tgtEl>
                                         <p:attrNameLst>
                                           <p:attrName>style.visibility</p:attrName>
@@ -27874,7 +28196,7 @@
             <p:spPr>
               <a:xfrm>
                 <a:off x="548640" y="1371600"/>
-                <a:ext cx="11064240" cy="1432560"/>
+                <a:ext cx="11064240" cy="463295"/>
               </a:xfrm>
               <a:prstGeom prst="rect">
                 <a:avLst/>
@@ -27991,6 +28313,615 @@
                   <a:t>.</a:t>
                 </a:r>
               </a:p>
+            </p:txBody>
+          </p:sp>
+        </mc:Choice>
+        <mc:Fallback>
+          <p:sp>
+            <p:nvSpPr>
+              <p:cNvPr id="7" name="TextBox 6"/>
+              <p:cNvSpPr txBox="1"/>
+              <p:nvPr/>
+            </p:nvSpPr>
+            <p:spPr>
+              <a:xfrm>
+                <a:off x="548640" y="1371600"/>
+                <a:ext cx="11064240" cy="463295"/>
+              </a:xfrm>
+              <a:prstGeom prst="rect">
+                <a:avLst/>
+              </a:prstGeom>
+              <a:noFill/>
+            </p:spPr>
+            <p:txBody>
+              <a:bodyPr wrap="square" anchor="t" lIns="45720" rIns="45720">
+                <a:spAutoFit/>
+              </a:bodyPr>
+              <a:lstStyle/>
+              <a:p>
+                <a:pPr algn="l">
+                  <a:spcAft>
+                    <a:spcPts val="800"/>
+                  </a:spcAft>
+                </a:pPr>
+                <a:r>
+                  <a:rPr sz="1900" b="1">
+                    <a:solidFill>
+                      <a:srgbClr val="1E293B"/>
+                    </a:solidFill>
+                    <a:latin typeface="Calibri"/>
+                  </a:rPr>
+                  <a:t>4.3.</a:t>
+                </a:r>
+                <a:r>
+                  <a:rPr sz="1900">
+                    <a:solidFill>
+                      <a:srgbClr val="1E293B"/>
+                    </a:solidFill>
+                    <a:latin typeface="Calibri"/>
+                  </a:rPr>
+                  <a:t> Chứng minh rằng tứ giác </a:t>
+                </a:r>
+                <a:r>
+                  <a:rPr lang="vi-VN"/>
+                  <a:t>ABCD</a:t>
+                </a:r>
+                <a:r>
+                  <a:rPr sz="1900">
+                    <a:solidFill>
+                      <a:srgbClr val="1E293B"/>
+                    </a:solidFill>
+                    <a:latin typeface="Calibri"/>
+                  </a:rPr>
+                  <a:t> là một hình bình hành khi và chỉ khi </a:t>
+                </a:r>
+                <a:r>
+                  <a:rPr lang="vi-VN"/>
+                  <a:t>\overrightarrow{BC}</a:t>
+                </a:r>
+                <a:r>
+                  <a:rPr sz="1900">
+                    <a:solidFill>
+                      <a:srgbClr val="1E293B"/>
+                    </a:solidFill>
+                    <a:latin typeface="Calibri"/>
+                  </a:rPr>
+                  <a:t> = </a:t>
+                </a:r>
+                <a:r>
+                  <a:rPr lang="vi-VN"/>
+                  <a:t>\overrightarrow{AD}</a:t>
+                </a:r>
+                <a:r>
+                  <a:rPr sz="1900">
+                    <a:solidFill>
+                      <a:srgbClr val="1E293B"/>
+                    </a:solidFill>
+                    <a:latin typeface="Calibri"/>
+                  </a:rPr>
+                  <a:t>.</a:t>
+                </a:r>
+              </a:p>
+            </p:txBody>
+          </p:sp>
+        </mc:Fallback>
+      </mc:AlternateContent>
+      <p:sp>
+        <p:nvSpPr>
+          <p:cNvPr id="8" name="s1_nen"/>
+          <p:cNvSpPr/>
+          <p:nvPr/>
+        </p:nvSpPr>
+        <p:spPr>
+          <a:xfrm>
+            <a:off x="548640" y="1898904"/>
+            <a:ext cx="11064240" cy="844295"/>
+          </a:xfrm>
+          <a:prstGeom prst="roundRect">
+            <a:avLst>
+              <a:gd name="adj" fmla="val 6000"/>
+            </a:avLst>
+          </a:prstGeom>
+          <a:solidFill>
+            <a:srgbClr val="ECFDF3"/>
+          </a:solidFill>
+          <a:ln w="19050">
+            <a:solidFill>
+              <a:srgbClr val="166534"/>
+            </a:solidFill>
+          </a:ln>
+          <a:effectLst/>
+        </p:spPr>
+        <p:style>
+          <a:lnRef idx="1">
+            <a:schemeClr val="accent1"/>
+          </a:lnRef>
+          <a:fillRef idx="3">
+            <a:schemeClr val="accent1"/>
+          </a:fillRef>
+          <a:effectRef idx="2">
+            <a:schemeClr val="accent1"/>
+          </a:effectRef>
+          <a:fontRef idx="minor">
+            <a:schemeClr val="lt1"/>
+          </a:fontRef>
+        </p:style>
+        <p:txBody>
+          <a:bodyPr rtlCol="0" anchor="ctr"/>
+          <a:lstStyle/>
+          <a:p>
+            <a:pPr algn="ctr"/>
+          </a:p>
+        </p:txBody>
+      </p:sp>
+      <mc:AlternateContent xmlns:mc="http://schemas.openxmlformats.org/markup-compatibility/2006">
+        <mc:Choice xmlns:a14="http://schemas.microsoft.com/office/drawing/2010/main" Requires="a14">
+          <p:sp>
+            <p:nvSpPr>
+              <p:cNvPr id="9" name="s1_chu"/>
+              <p:cNvSpPr txBox="1"/>
+              <p:nvPr/>
+            </p:nvSpPr>
+            <p:spPr>
+              <a:xfrm>
+                <a:off x="713232" y="1935480"/>
+                <a:ext cx="10735056" cy="771143"/>
+              </a:xfrm>
+              <a:prstGeom prst="rect">
+                <a:avLst/>
+              </a:prstGeom>
+              <a:noFill/>
+            </p:spPr>
+            <p:txBody>
+              <a:bodyPr wrap="square" anchor="ctr" lIns="45720" rIns="45720">
+                <a:spAutoFit/>
+              </a:bodyPr>
+              <a:lstStyle/>
+              <a:p>
+                <a:pPr algn="l">
+                  <a:spcAft>
+                    <a:spcPts val="800"/>
+                  </a:spcAft>
+                </a:pPr>
+                <a:r>
+                  <a:rPr sz="1900" b="1">
+                    <a:solidFill>
+                      <a:srgbClr val="1E293B"/>
+                    </a:solidFill>
+                    <a:latin typeface="Calibri"/>
+                  </a:rPr>
+                  <a:t>4.3.</a:t>
+                </a:r>
+                <a:r>
+                  <a:rPr sz="1900">
+                    <a:solidFill>
+                      <a:srgbClr val="1E293B"/>
+                    </a:solidFill>
+                    <a:latin typeface="Calibri"/>
+                  </a:rPr>
+                  <a:t> </a:t>
+                </a:r>
+                <a14:m>
+                  <m:oMath xmlns:m="http://schemas.openxmlformats.org/officeDocument/2006/math">
+                    <m:r>
+                      <a:rPr lang="vi-VN" sz="1900" b="0">
+                        <a:solidFill>
+                          <a:srgbClr val="1E293B"/>
+                        </a:solidFill>
+                        <a:latin typeface="Cambria Math" panose="02040503050406030204" pitchFamily="18" charset="0"/>
+                      </a:rPr>
+                      <m:t>ABCD</m:t>
+                    </m:r>
+                  </m:oMath>
+                </a14:m>
+                <a:r>
+                  <a:rPr sz="1900">
+                    <a:solidFill>
+                      <a:srgbClr val="1E293B"/>
+                    </a:solidFill>
+                    <a:latin typeface="Calibri"/>
+                  </a:rPr>
+                  <a:t> là hình bình hành ⇒ </a:t>
+                </a:r>
+                <a14:m>
+                  <m:oMath xmlns:m="http://schemas.openxmlformats.org/officeDocument/2006/math">
+                    <m:r>
+                      <a:rPr lang="vi-VN" sz="1900" b="0">
+                        <a:solidFill>
+                          <a:srgbClr val="1E293B"/>
+                        </a:solidFill>
+                        <a:latin typeface="Cambria Math" panose="02040503050406030204" pitchFamily="18" charset="0"/>
+                      </a:rPr>
+                      <m:t>BC∥AD</m:t>
+                    </m:r>
+                  </m:oMath>
+                </a14:m>
+                <a:r>
+                  <a:rPr sz="1900">
+                    <a:solidFill>
+                      <a:srgbClr val="1E293B"/>
+                    </a:solidFill>
+                    <a:latin typeface="Calibri"/>
+                  </a:rPr>
+                  <a:t>, </a:t>
+                </a:r>
+                <a14:m>
+                  <m:oMath xmlns:m="http://schemas.openxmlformats.org/officeDocument/2006/math">
+                    <m:r>
+                      <a:rPr lang="vi-VN" sz="1900" b="0">
+                        <a:solidFill>
+                          <a:srgbClr val="1E293B"/>
+                        </a:solidFill>
+                        <a:latin typeface="Cambria Math" panose="02040503050406030204" pitchFamily="18" charset="0"/>
+                      </a:rPr>
+                      <m:t>BC=AD</m:t>
+                    </m:r>
+                  </m:oMath>
+                </a14:m>
+                <a:r>
+                  <a:rPr sz="1900">
+                    <a:solidFill>
+                      <a:srgbClr val="1E293B"/>
+                    </a:solidFill>
+                    <a:latin typeface="Calibri"/>
+                  </a:rPr>
+                  <a:t> ⇒ </a:t>
+                </a:r>
+                <a14:m>
+                  <m:oMath xmlns:m="http://schemas.openxmlformats.org/officeDocument/2006/math">
+                    <m:acc>
+                      <m:accPr>
+                        <m:chr m:val="⃗"/>
+                      </m:accPr>
+                      <m:e>
+                        <m:r>
+                          <a:rPr lang="vi-VN" sz="1900" b="0">
+                            <a:solidFill>
+                              <a:srgbClr val="1E293B"/>
+                            </a:solidFill>
+                            <a:latin typeface="Cambria Math" panose="02040503050406030204" pitchFamily="18" charset="0"/>
+                          </a:rPr>
+                          <m:t>BC</m:t>
+                        </m:r>
+                      </m:e>
+                    </m:acc>
+                  </m:oMath>
+                </a14:m>
+                <a:r>
+                  <a:rPr sz="1900">
+                    <a:solidFill>
+                      <a:srgbClr val="1E293B"/>
+                    </a:solidFill>
+                    <a:latin typeface="Calibri"/>
+                  </a:rPr>
+                  <a:t> = </a:t>
+                </a:r>
+                <a14:m>
+                  <m:oMath xmlns:m="http://schemas.openxmlformats.org/officeDocument/2006/math">
+                    <m:acc>
+                      <m:accPr>
+                        <m:chr m:val="⃗"/>
+                      </m:accPr>
+                      <m:e>
+                        <m:r>
+                          <a:rPr lang="vi-VN" sz="1900" b="0">
+                            <a:solidFill>
+                              <a:srgbClr val="1E293B"/>
+                            </a:solidFill>
+                            <a:latin typeface="Cambria Math" panose="02040503050406030204" pitchFamily="18" charset="0"/>
+                          </a:rPr>
+                          <m:t>AD</m:t>
+                        </m:r>
+                      </m:e>
+                    </m:acc>
+                  </m:oMath>
+                </a14:m>
+                <a:r>
+                  <a:rPr sz="1900">
+                    <a:solidFill>
+                      <a:srgbClr val="1E293B"/>
+                    </a:solidFill>
+                    <a:latin typeface="Calibri"/>
+                  </a:rPr>
+                  <a:t>. Ngược lại, </a:t>
+                </a:r>
+                <a14:m>
+                  <m:oMath xmlns:m="http://schemas.openxmlformats.org/officeDocument/2006/math">
+                    <m:acc>
+                      <m:accPr>
+                        <m:chr m:val="⃗"/>
+                      </m:accPr>
+                      <m:e>
+                        <m:r>
+                          <a:rPr lang="vi-VN" sz="1900" b="0">
+                            <a:solidFill>
+                              <a:srgbClr val="1E293B"/>
+                            </a:solidFill>
+                            <a:latin typeface="Cambria Math" panose="02040503050406030204" pitchFamily="18" charset="0"/>
+                          </a:rPr>
+                          <m:t>BC</m:t>
+                        </m:r>
+                      </m:e>
+                    </m:acc>
+                  </m:oMath>
+                </a14:m>
+                <a:r>
+                  <a:rPr sz="1900">
+                    <a:solidFill>
+                      <a:srgbClr val="1E293B"/>
+                    </a:solidFill>
+                    <a:latin typeface="Calibri"/>
+                  </a:rPr>
+                  <a:t> = </a:t>
+                </a:r>
+                <a14:m>
+                  <m:oMath xmlns:m="http://schemas.openxmlformats.org/officeDocument/2006/math">
+                    <m:acc>
+                      <m:accPr>
+                        <m:chr m:val="⃗"/>
+                      </m:accPr>
+                      <m:e>
+                        <m:r>
+                          <a:rPr lang="vi-VN" sz="1900" b="0">
+                            <a:solidFill>
+                              <a:srgbClr val="1E293B"/>
+                            </a:solidFill>
+                            <a:latin typeface="Cambria Math" panose="02040503050406030204" pitchFamily="18" charset="0"/>
+                          </a:rPr>
+                          <m:t>AD</m:t>
+                        </m:r>
+                      </m:e>
+                    </m:acc>
+                  </m:oMath>
+                </a14:m>
+                <a:r>
+                  <a:rPr sz="1900">
+                    <a:solidFill>
+                      <a:srgbClr val="1E293B"/>
+                    </a:solidFill>
+                    <a:latin typeface="Calibri"/>
+                  </a:rPr>
+                  <a:t> ⇒ </a:t>
+                </a:r>
+                <a14:m>
+                  <m:oMath xmlns:m="http://schemas.openxmlformats.org/officeDocument/2006/math">
+                    <m:r>
+                      <a:rPr lang="vi-VN" sz="1900" b="0">
+                        <a:solidFill>
+                          <a:srgbClr val="1E293B"/>
+                        </a:solidFill>
+                        <a:latin typeface="Cambria Math" panose="02040503050406030204" pitchFamily="18" charset="0"/>
+                      </a:rPr>
+                      <m:t>BC=AD</m:t>
+                    </m:r>
+                  </m:oMath>
+                </a14:m>
+                <a:r>
+                  <a:rPr sz="1900">
+                    <a:solidFill>
+                      <a:srgbClr val="1E293B"/>
+                    </a:solidFill>
+                    <a:latin typeface="Calibri"/>
+                  </a:rPr>
+                  <a:t>, </a:t>
+                </a:r>
+                <a14:m>
+                  <m:oMath xmlns:m="http://schemas.openxmlformats.org/officeDocument/2006/math">
+                    <m:r>
+                      <a:rPr lang="vi-VN" sz="1900" b="0">
+                        <a:solidFill>
+                          <a:srgbClr val="1E293B"/>
+                        </a:solidFill>
+                        <a:latin typeface="Cambria Math" panose="02040503050406030204" pitchFamily="18" charset="0"/>
+                      </a:rPr>
+                      <m:t>BC∥AD</m:t>
+                    </m:r>
+                  </m:oMath>
+                </a14:m>
+                <a:r>
+                  <a:rPr sz="1900">
+                    <a:solidFill>
+                      <a:srgbClr val="1E293B"/>
+                    </a:solidFill>
+                    <a:latin typeface="Calibri"/>
+                  </a:rPr>
+                  <a:t> (không trùng) ⇒ hình bình hành.</a:t>
+                </a:r>
+              </a:p>
+            </p:txBody>
+          </p:sp>
+        </mc:Choice>
+        <mc:Fallback>
+          <p:sp>
+            <p:nvSpPr>
+              <p:cNvPr id="9" name="TextBox 8"/>
+              <p:cNvSpPr txBox="1"/>
+              <p:nvPr/>
+            </p:nvSpPr>
+            <p:spPr>
+              <a:xfrm>
+                <a:off x="713232" y="1935480"/>
+                <a:ext cx="10735056" cy="771143"/>
+              </a:xfrm>
+              <a:prstGeom prst="rect">
+                <a:avLst/>
+              </a:prstGeom>
+              <a:noFill/>
+            </p:spPr>
+            <p:txBody>
+              <a:bodyPr wrap="square" anchor="ctr" lIns="45720" rIns="45720">
+                <a:spAutoFit/>
+              </a:bodyPr>
+              <a:lstStyle/>
+              <a:p>
+                <a:pPr algn="l">
+                  <a:spcAft>
+                    <a:spcPts val="800"/>
+                  </a:spcAft>
+                </a:pPr>
+                <a:r>
+                  <a:rPr sz="1900" b="1">
+                    <a:solidFill>
+                      <a:srgbClr val="1E293B"/>
+                    </a:solidFill>
+                    <a:latin typeface="Calibri"/>
+                  </a:rPr>
+                  <a:t>4.3.</a:t>
+                </a:r>
+                <a:r>
+                  <a:rPr sz="1900">
+                    <a:solidFill>
+                      <a:srgbClr val="1E293B"/>
+                    </a:solidFill>
+                    <a:latin typeface="Calibri"/>
+                  </a:rPr>
+                  <a:t> </a:t>
+                </a:r>
+                <a:r>
+                  <a:rPr lang="vi-VN"/>
+                  <a:t>ABCD</a:t>
+                </a:r>
+                <a:r>
+                  <a:rPr sz="1900">
+                    <a:solidFill>
+                      <a:srgbClr val="1E293B"/>
+                    </a:solidFill>
+                    <a:latin typeface="Calibri"/>
+                  </a:rPr>
+                  <a:t> là hình bình hành ⇒ </a:t>
+                </a:r>
+                <a:r>
+                  <a:rPr lang="vi-VN"/>
+                  <a:t>BC\parallel AD</a:t>
+                </a:r>
+                <a:r>
+                  <a:rPr sz="1900">
+                    <a:solidFill>
+                      <a:srgbClr val="1E293B"/>
+                    </a:solidFill>
+                    <a:latin typeface="Calibri"/>
+                  </a:rPr>
+                  <a:t>, </a:t>
+                </a:r>
+                <a:r>
+                  <a:rPr lang="vi-VN"/>
+                  <a:t>BC=AD</a:t>
+                </a:r>
+                <a:r>
+                  <a:rPr sz="1900">
+                    <a:solidFill>
+                      <a:srgbClr val="1E293B"/>
+                    </a:solidFill>
+                    <a:latin typeface="Calibri"/>
+                  </a:rPr>
+                  <a:t> ⇒ </a:t>
+                </a:r>
+                <a:r>
+                  <a:rPr lang="vi-VN"/>
+                  <a:t>\overrightarrow{BC}</a:t>
+                </a:r>
+                <a:r>
+                  <a:rPr sz="1900">
+                    <a:solidFill>
+                      <a:srgbClr val="1E293B"/>
+                    </a:solidFill>
+                    <a:latin typeface="Calibri"/>
+                  </a:rPr>
+                  <a:t> = </a:t>
+                </a:r>
+                <a:r>
+                  <a:rPr lang="vi-VN"/>
+                  <a:t>\overrightarrow{AD}</a:t>
+                </a:r>
+                <a:r>
+                  <a:rPr sz="1900">
+                    <a:solidFill>
+                      <a:srgbClr val="1E293B"/>
+                    </a:solidFill>
+                    <a:latin typeface="Calibri"/>
+                  </a:rPr>
+                  <a:t>. Ngược lại, </a:t>
+                </a:r>
+                <a:r>
+                  <a:rPr lang="vi-VN"/>
+                  <a:t>\overrightarrow{BC}</a:t>
+                </a:r>
+                <a:r>
+                  <a:rPr sz="1900">
+                    <a:solidFill>
+                      <a:srgbClr val="1E293B"/>
+                    </a:solidFill>
+                    <a:latin typeface="Calibri"/>
+                  </a:rPr>
+                  <a:t> = </a:t>
+                </a:r>
+                <a:r>
+                  <a:rPr lang="vi-VN"/>
+                  <a:t>\overrightarrow{AD}</a:t>
+                </a:r>
+                <a:r>
+                  <a:rPr sz="1900">
+                    <a:solidFill>
+                      <a:srgbClr val="1E293B"/>
+                    </a:solidFill>
+                    <a:latin typeface="Calibri"/>
+                  </a:rPr>
+                  <a:t> ⇒ </a:t>
+                </a:r>
+                <a:r>
+                  <a:rPr lang="vi-VN"/>
+                  <a:t>BC=AD</a:t>
+                </a:r>
+                <a:r>
+                  <a:rPr sz="1900">
+                    <a:solidFill>
+                      <a:srgbClr val="1E293B"/>
+                    </a:solidFill>
+                    <a:latin typeface="Calibri"/>
+                  </a:rPr>
+                  <a:t>, </a:t>
+                </a:r>
+                <a:r>
+                  <a:rPr lang="vi-VN"/>
+                  <a:t>BC\parallel AD</a:t>
+                </a:r>
+                <a:r>
+                  <a:rPr sz="1900">
+                    <a:solidFill>
+                      <a:srgbClr val="1E293B"/>
+                    </a:solidFill>
+                    <a:latin typeface="Calibri"/>
+                  </a:rPr>
+                  <a:t> (không trùng) ⇒ hình bình hành.</a:t>
+                </a:r>
+              </a:p>
+            </p:txBody>
+          </p:sp>
+        </mc:Fallback>
+      </mc:AlternateContent>
+      <mc:AlternateContent xmlns:mc="http://schemas.openxmlformats.org/markup-compatibility/2006">
+        <mc:Choice xmlns:a14="http://schemas.microsoft.com/office/drawing/2010/main" Requires="a14">
+          <p:sp>
+            <p:nvSpPr>
+              <p:cNvPr id="10" name="s2_chu"/>
+              <p:cNvSpPr txBox="1"/>
+              <p:nvPr/>
+            </p:nvSpPr>
+            <p:spPr>
+              <a:xfrm>
+                <a:off x="548640" y="2807208"/>
+                <a:ext cx="11064240" cy="1042415"/>
+              </a:xfrm>
+              <a:prstGeom prst="rect">
+                <a:avLst/>
+              </a:prstGeom>
+              <a:noFill/>
+            </p:spPr>
+            <p:txBody>
+              <a:bodyPr wrap="square" anchor="t" lIns="45720" rIns="45720">
+                <a:spAutoFit/>
+              </a:bodyPr>
+              <a:lstStyle/>
               <a:p>
                 <a:pPr algn="l">
                   <a:spcAft>
@@ -28290,14 +29221,14 @@
         <mc:Fallback>
           <p:sp>
             <p:nvSpPr>
-              <p:cNvPr id="7" name="TextBox 6"/>
+              <p:cNvPr id="10" name="TextBox 9"/>
               <p:cNvSpPr txBox="1"/>
               <p:nvPr/>
             </p:nvSpPr>
             <p:spPr>
               <a:xfrm>
-                <a:off x="548640" y="1371600"/>
-                <a:ext cx="11064240" cy="1432560"/>
+                <a:off x="548640" y="2807208"/>
+                <a:ext cx="11064240" cy="1042415"/>
               </a:xfrm>
               <a:prstGeom prst="rect">
                 <a:avLst/>
@@ -28322,70 +29253,6 @@
                     </a:solidFill>
                     <a:latin typeface="Calibri"/>
                   </a:rPr>
-                  <a:t>4.3.</a:t>
-                </a:r>
-                <a:r>
-                  <a:rPr sz="1900">
-                    <a:solidFill>
-                      <a:srgbClr val="1E293B"/>
-                    </a:solidFill>
-                    <a:latin typeface="Calibri"/>
-                  </a:rPr>
-                  <a:t> Chứng minh rằng tứ giác </a:t>
-                </a:r>
-                <a:r>
-                  <a:rPr lang="vi-VN"/>
-                  <a:t>ABCD</a:t>
-                </a:r>
-                <a:r>
-                  <a:rPr sz="1900">
-                    <a:solidFill>
-                      <a:srgbClr val="1E293B"/>
-                    </a:solidFill>
-                    <a:latin typeface="Calibri"/>
-                  </a:rPr>
-                  <a:t> là một hình bình hành khi và chỉ khi </a:t>
-                </a:r>
-                <a:r>
-                  <a:rPr lang="vi-VN"/>
-                  <a:t>\overrightarrow{BC}</a:t>
-                </a:r>
-                <a:r>
-                  <a:rPr sz="1900">
-                    <a:solidFill>
-                      <a:srgbClr val="1E293B"/>
-                    </a:solidFill>
-                    <a:latin typeface="Calibri"/>
-                  </a:rPr>
-                  <a:t> = </a:t>
-                </a:r>
-                <a:r>
-                  <a:rPr lang="vi-VN"/>
-                  <a:t>\overrightarrow{AD}</a:t>
-                </a:r>
-                <a:r>
-                  <a:rPr sz="1900">
-                    <a:solidFill>
-                      <a:srgbClr val="1E293B"/>
-                    </a:solidFill>
-                    <a:latin typeface="Calibri"/>
-                  </a:rPr>
-                  <a:t>.</a:t>
-                </a:r>
-              </a:p>
-              <a:p>
-                <a:pPr algn="l">
-                  <a:spcAft>
-                    <a:spcPts val="800"/>
-                  </a:spcAft>
-                </a:pPr>
-                <a:r>
-                  <a:rPr sz="1900" b="1">
-                    <a:solidFill>
-                      <a:srgbClr val="1E293B"/>
-                    </a:solidFill>
-                    <a:latin typeface="Calibri"/>
-                  </a:rPr>
                   <a:t>4.4.</a:t>
                 </a:r>
                 <a:r>
@@ -28482,13 +29349,13 @@
       </mc:AlternateContent>
       <p:sp>
         <p:nvSpPr>
-          <p:cNvPr id="8" name="s1_nen"/>
+          <p:cNvPr id="11" name="s3_nen"/>
           <p:cNvSpPr/>
           <p:nvPr/>
         </p:nvSpPr>
         <p:spPr>
           <a:xfrm>
-            <a:off x="548640" y="2895600"/>
+            <a:off x="548640" y="3913631"/>
             <a:ext cx="11064240" cy="844295"/>
           </a:xfrm>
           <a:prstGeom prst="roundRect">
@@ -28532,506 +29399,13 @@
         <mc:Choice xmlns:a14="http://schemas.microsoft.com/office/drawing/2010/main" Requires="a14">
           <p:sp>
             <p:nvSpPr>
-              <p:cNvPr id="9" name="s1_chu"/>
+              <p:cNvPr id="12" name="s3_chu"/>
               <p:cNvSpPr txBox="1"/>
               <p:nvPr/>
             </p:nvSpPr>
             <p:spPr>
               <a:xfrm>
-                <a:off x="713232" y="2932176"/>
-                <a:ext cx="10735056" cy="771143"/>
-              </a:xfrm>
-              <a:prstGeom prst="rect">
-                <a:avLst/>
-              </a:prstGeom>
-              <a:noFill/>
-            </p:spPr>
-            <p:txBody>
-              <a:bodyPr wrap="square" anchor="ctr" lIns="45720" rIns="45720">
-                <a:spAutoFit/>
-              </a:bodyPr>
-              <a:lstStyle/>
-              <a:p>
-                <a:pPr algn="l">
-                  <a:spcAft>
-                    <a:spcPts val="800"/>
-                  </a:spcAft>
-                </a:pPr>
-                <a:r>
-                  <a:rPr sz="1900" b="1">
-                    <a:solidFill>
-                      <a:srgbClr val="1E293B"/>
-                    </a:solidFill>
-                    <a:latin typeface="Calibri"/>
-                  </a:rPr>
-                  <a:t>4.3.</a:t>
-                </a:r>
-                <a:r>
-                  <a:rPr sz="1900">
-                    <a:solidFill>
-                      <a:srgbClr val="1E293B"/>
-                    </a:solidFill>
-                    <a:latin typeface="Calibri"/>
-                  </a:rPr>
-                  <a:t> </a:t>
-                </a:r>
-                <a14:m>
-                  <m:oMath xmlns:m="http://schemas.openxmlformats.org/officeDocument/2006/math">
-                    <m:r>
-                      <a:rPr lang="vi-VN" sz="1900" b="0">
-                        <a:solidFill>
-                          <a:srgbClr val="1E293B"/>
-                        </a:solidFill>
-                        <a:latin typeface="Cambria Math" panose="02040503050406030204" pitchFamily="18" charset="0"/>
-                      </a:rPr>
-                      <m:t>ABCD</m:t>
-                    </m:r>
-                  </m:oMath>
-                </a14:m>
-                <a:r>
-                  <a:rPr sz="1900">
-                    <a:solidFill>
-                      <a:srgbClr val="1E293B"/>
-                    </a:solidFill>
-                    <a:latin typeface="Calibri"/>
-                  </a:rPr>
-                  <a:t> là hình bình hành ⇒ </a:t>
-                </a:r>
-                <a14:m>
-                  <m:oMath xmlns:m="http://schemas.openxmlformats.org/officeDocument/2006/math">
-                    <m:r>
-                      <a:rPr lang="vi-VN" sz="1900" b="0">
-                        <a:solidFill>
-                          <a:srgbClr val="1E293B"/>
-                        </a:solidFill>
-                        <a:latin typeface="Cambria Math" panose="02040503050406030204" pitchFamily="18" charset="0"/>
-                      </a:rPr>
-                      <m:t>BC∥AD</m:t>
-                    </m:r>
-                  </m:oMath>
-                </a14:m>
-                <a:r>
-                  <a:rPr sz="1900">
-                    <a:solidFill>
-                      <a:srgbClr val="1E293B"/>
-                    </a:solidFill>
-                    <a:latin typeface="Calibri"/>
-                  </a:rPr>
-                  <a:t>, </a:t>
-                </a:r>
-                <a14:m>
-                  <m:oMath xmlns:m="http://schemas.openxmlformats.org/officeDocument/2006/math">
-                    <m:r>
-                      <a:rPr lang="vi-VN" sz="1900" b="0">
-                        <a:solidFill>
-                          <a:srgbClr val="1E293B"/>
-                        </a:solidFill>
-                        <a:latin typeface="Cambria Math" panose="02040503050406030204" pitchFamily="18" charset="0"/>
-                      </a:rPr>
-                      <m:t>BC=AD</m:t>
-                    </m:r>
-                  </m:oMath>
-                </a14:m>
-                <a:r>
-                  <a:rPr sz="1900">
-                    <a:solidFill>
-                      <a:srgbClr val="1E293B"/>
-                    </a:solidFill>
-                    <a:latin typeface="Calibri"/>
-                  </a:rPr>
-                  <a:t> ⇒ </a:t>
-                </a:r>
-                <a14:m>
-                  <m:oMath xmlns:m="http://schemas.openxmlformats.org/officeDocument/2006/math">
-                    <m:acc>
-                      <m:accPr>
-                        <m:chr m:val="⃗"/>
-                      </m:accPr>
-                      <m:e>
-                        <m:r>
-                          <a:rPr lang="vi-VN" sz="1900" b="0">
-                            <a:solidFill>
-                              <a:srgbClr val="1E293B"/>
-                            </a:solidFill>
-                            <a:latin typeface="Cambria Math" panose="02040503050406030204" pitchFamily="18" charset="0"/>
-                          </a:rPr>
-                          <m:t>BC</m:t>
-                        </m:r>
-                      </m:e>
-                    </m:acc>
-                  </m:oMath>
-                </a14:m>
-                <a:r>
-                  <a:rPr sz="1900">
-                    <a:solidFill>
-                      <a:srgbClr val="1E293B"/>
-                    </a:solidFill>
-                    <a:latin typeface="Calibri"/>
-                  </a:rPr>
-                  <a:t> = </a:t>
-                </a:r>
-                <a14:m>
-                  <m:oMath xmlns:m="http://schemas.openxmlformats.org/officeDocument/2006/math">
-                    <m:acc>
-                      <m:accPr>
-                        <m:chr m:val="⃗"/>
-                      </m:accPr>
-                      <m:e>
-                        <m:r>
-                          <a:rPr lang="vi-VN" sz="1900" b="0">
-                            <a:solidFill>
-                              <a:srgbClr val="1E293B"/>
-                            </a:solidFill>
-                            <a:latin typeface="Cambria Math" panose="02040503050406030204" pitchFamily="18" charset="0"/>
-                          </a:rPr>
-                          <m:t>AD</m:t>
-                        </m:r>
-                      </m:e>
-                    </m:acc>
-                  </m:oMath>
-                </a14:m>
-                <a:r>
-                  <a:rPr sz="1900">
-                    <a:solidFill>
-                      <a:srgbClr val="1E293B"/>
-                    </a:solidFill>
-                    <a:latin typeface="Calibri"/>
-                  </a:rPr>
-                  <a:t>. Ngược lại, </a:t>
-                </a:r>
-                <a14:m>
-                  <m:oMath xmlns:m="http://schemas.openxmlformats.org/officeDocument/2006/math">
-                    <m:acc>
-                      <m:accPr>
-                        <m:chr m:val="⃗"/>
-                      </m:accPr>
-                      <m:e>
-                        <m:r>
-                          <a:rPr lang="vi-VN" sz="1900" b="0">
-                            <a:solidFill>
-                              <a:srgbClr val="1E293B"/>
-                            </a:solidFill>
-                            <a:latin typeface="Cambria Math" panose="02040503050406030204" pitchFamily="18" charset="0"/>
-                          </a:rPr>
-                          <m:t>BC</m:t>
-                        </m:r>
-                      </m:e>
-                    </m:acc>
-                  </m:oMath>
-                </a14:m>
-                <a:r>
-                  <a:rPr sz="1900">
-                    <a:solidFill>
-                      <a:srgbClr val="1E293B"/>
-                    </a:solidFill>
-                    <a:latin typeface="Calibri"/>
-                  </a:rPr>
-                  <a:t> = </a:t>
-                </a:r>
-                <a14:m>
-                  <m:oMath xmlns:m="http://schemas.openxmlformats.org/officeDocument/2006/math">
-                    <m:acc>
-                      <m:accPr>
-                        <m:chr m:val="⃗"/>
-                      </m:accPr>
-                      <m:e>
-                        <m:r>
-                          <a:rPr lang="vi-VN" sz="1900" b="0">
-                            <a:solidFill>
-                              <a:srgbClr val="1E293B"/>
-                            </a:solidFill>
-                            <a:latin typeface="Cambria Math" panose="02040503050406030204" pitchFamily="18" charset="0"/>
-                          </a:rPr>
-                          <m:t>AD</m:t>
-                        </m:r>
-                      </m:e>
-                    </m:acc>
-                  </m:oMath>
-                </a14:m>
-                <a:r>
-                  <a:rPr sz="1900">
-                    <a:solidFill>
-                      <a:srgbClr val="1E293B"/>
-                    </a:solidFill>
-                    <a:latin typeface="Calibri"/>
-                  </a:rPr>
-                  <a:t> ⇒ </a:t>
-                </a:r>
-                <a14:m>
-                  <m:oMath xmlns:m="http://schemas.openxmlformats.org/officeDocument/2006/math">
-                    <m:r>
-                      <a:rPr lang="vi-VN" sz="1900" b="0">
-                        <a:solidFill>
-                          <a:srgbClr val="1E293B"/>
-                        </a:solidFill>
-                        <a:latin typeface="Cambria Math" panose="02040503050406030204" pitchFamily="18" charset="0"/>
-                      </a:rPr>
-                      <m:t>BC=AD</m:t>
-                    </m:r>
-                  </m:oMath>
-                </a14:m>
-                <a:r>
-                  <a:rPr sz="1900">
-                    <a:solidFill>
-                      <a:srgbClr val="1E293B"/>
-                    </a:solidFill>
-                    <a:latin typeface="Calibri"/>
-                  </a:rPr>
-                  <a:t>, </a:t>
-                </a:r>
-                <a14:m>
-                  <m:oMath xmlns:m="http://schemas.openxmlformats.org/officeDocument/2006/math">
-                    <m:r>
-                      <a:rPr lang="vi-VN" sz="1900" b="0">
-                        <a:solidFill>
-                          <a:srgbClr val="1E293B"/>
-                        </a:solidFill>
-                        <a:latin typeface="Cambria Math" panose="02040503050406030204" pitchFamily="18" charset="0"/>
-                      </a:rPr>
-                      <m:t>BC∥AD</m:t>
-                    </m:r>
-                  </m:oMath>
-                </a14:m>
-                <a:r>
-                  <a:rPr sz="1900">
-                    <a:solidFill>
-                      <a:srgbClr val="1E293B"/>
-                    </a:solidFill>
-                    <a:latin typeface="Calibri"/>
-                  </a:rPr>
-                  <a:t> (không trùng) ⇒ hình bình hành.</a:t>
-                </a:r>
-              </a:p>
-            </p:txBody>
-          </p:sp>
-        </mc:Choice>
-        <mc:Fallback>
-          <p:sp>
-            <p:nvSpPr>
-              <p:cNvPr id="9" name="TextBox 8"/>
-              <p:cNvSpPr txBox="1"/>
-              <p:nvPr/>
-            </p:nvSpPr>
-            <p:spPr>
-              <a:xfrm>
-                <a:off x="713232" y="2932176"/>
-                <a:ext cx="10735056" cy="771143"/>
-              </a:xfrm>
-              <a:prstGeom prst="rect">
-                <a:avLst/>
-              </a:prstGeom>
-              <a:noFill/>
-            </p:spPr>
-            <p:txBody>
-              <a:bodyPr wrap="square" anchor="ctr" lIns="45720" rIns="45720">
-                <a:spAutoFit/>
-              </a:bodyPr>
-              <a:lstStyle/>
-              <a:p>
-                <a:pPr algn="l">
-                  <a:spcAft>
-                    <a:spcPts val="800"/>
-                  </a:spcAft>
-                </a:pPr>
-                <a:r>
-                  <a:rPr sz="1900" b="1">
-                    <a:solidFill>
-                      <a:srgbClr val="1E293B"/>
-                    </a:solidFill>
-                    <a:latin typeface="Calibri"/>
-                  </a:rPr>
-                  <a:t>4.3.</a:t>
-                </a:r>
-                <a:r>
-                  <a:rPr sz="1900">
-                    <a:solidFill>
-                      <a:srgbClr val="1E293B"/>
-                    </a:solidFill>
-                    <a:latin typeface="Calibri"/>
-                  </a:rPr>
-                  <a:t> </a:t>
-                </a:r>
-                <a:r>
-                  <a:rPr lang="vi-VN"/>
-                  <a:t>ABCD</a:t>
-                </a:r>
-                <a:r>
-                  <a:rPr sz="1900">
-                    <a:solidFill>
-                      <a:srgbClr val="1E293B"/>
-                    </a:solidFill>
-                    <a:latin typeface="Calibri"/>
-                  </a:rPr>
-                  <a:t> là hình bình hành ⇒ </a:t>
-                </a:r>
-                <a:r>
-                  <a:rPr lang="vi-VN"/>
-                  <a:t>BC\parallel AD</a:t>
-                </a:r>
-                <a:r>
-                  <a:rPr sz="1900">
-                    <a:solidFill>
-                      <a:srgbClr val="1E293B"/>
-                    </a:solidFill>
-                    <a:latin typeface="Calibri"/>
-                  </a:rPr>
-                  <a:t>, </a:t>
-                </a:r>
-                <a:r>
-                  <a:rPr lang="vi-VN"/>
-                  <a:t>BC=AD</a:t>
-                </a:r>
-                <a:r>
-                  <a:rPr sz="1900">
-                    <a:solidFill>
-                      <a:srgbClr val="1E293B"/>
-                    </a:solidFill>
-                    <a:latin typeface="Calibri"/>
-                  </a:rPr>
-                  <a:t> ⇒ </a:t>
-                </a:r>
-                <a:r>
-                  <a:rPr lang="vi-VN"/>
-                  <a:t>\overrightarrow{BC}</a:t>
-                </a:r>
-                <a:r>
-                  <a:rPr sz="1900">
-                    <a:solidFill>
-                      <a:srgbClr val="1E293B"/>
-                    </a:solidFill>
-                    <a:latin typeface="Calibri"/>
-                  </a:rPr>
-                  <a:t> = </a:t>
-                </a:r>
-                <a:r>
-                  <a:rPr lang="vi-VN"/>
-                  <a:t>\overrightarrow{AD}</a:t>
-                </a:r>
-                <a:r>
-                  <a:rPr sz="1900">
-                    <a:solidFill>
-                      <a:srgbClr val="1E293B"/>
-                    </a:solidFill>
-                    <a:latin typeface="Calibri"/>
-                  </a:rPr>
-                  <a:t>. Ngược lại, </a:t>
-                </a:r>
-                <a:r>
-                  <a:rPr lang="vi-VN"/>
-                  <a:t>\overrightarrow{BC}</a:t>
-                </a:r>
-                <a:r>
-                  <a:rPr sz="1900">
-                    <a:solidFill>
-                      <a:srgbClr val="1E293B"/>
-                    </a:solidFill>
-                    <a:latin typeface="Calibri"/>
-                  </a:rPr>
-                  <a:t> = </a:t>
-                </a:r>
-                <a:r>
-                  <a:rPr lang="vi-VN"/>
-                  <a:t>\overrightarrow{AD}</a:t>
-                </a:r>
-                <a:r>
-                  <a:rPr sz="1900">
-                    <a:solidFill>
-                      <a:srgbClr val="1E293B"/>
-                    </a:solidFill>
-                    <a:latin typeface="Calibri"/>
-                  </a:rPr>
-                  <a:t> ⇒ </a:t>
-                </a:r>
-                <a:r>
-                  <a:rPr lang="vi-VN"/>
-                  <a:t>BC=AD</a:t>
-                </a:r>
-                <a:r>
-                  <a:rPr sz="1900">
-                    <a:solidFill>
-                      <a:srgbClr val="1E293B"/>
-                    </a:solidFill>
-                    <a:latin typeface="Calibri"/>
-                  </a:rPr>
-                  <a:t>, </a:t>
-                </a:r>
-                <a:r>
-                  <a:rPr lang="vi-VN"/>
-                  <a:t>BC\parallel AD</a:t>
-                </a:r>
-                <a:r>
-                  <a:rPr sz="1900">
-                    <a:solidFill>
-                      <a:srgbClr val="1E293B"/>
-                    </a:solidFill>
-                    <a:latin typeface="Calibri"/>
-                  </a:rPr>
-                  <a:t> (không trùng) ⇒ hình bình hành.</a:t>
-                </a:r>
-              </a:p>
-            </p:txBody>
-          </p:sp>
-        </mc:Fallback>
-      </mc:AlternateContent>
-      <p:sp>
-        <p:nvSpPr>
-          <p:cNvPr id="10" name="s2_nen"/>
-          <p:cNvSpPr/>
-          <p:nvPr/>
-        </p:nvSpPr>
-        <p:spPr>
-          <a:xfrm>
-            <a:off x="548640" y="3794759"/>
-            <a:ext cx="11064240" cy="844295"/>
-          </a:xfrm>
-          <a:prstGeom prst="roundRect">
-            <a:avLst>
-              <a:gd name="adj" fmla="val 6000"/>
-            </a:avLst>
-          </a:prstGeom>
-          <a:solidFill>
-            <a:srgbClr val="ECFDF3"/>
-          </a:solidFill>
-          <a:ln w="19050">
-            <a:solidFill>
-              <a:srgbClr val="166534"/>
-            </a:solidFill>
-          </a:ln>
-          <a:effectLst/>
-        </p:spPr>
-        <p:style>
-          <a:lnRef idx="1">
-            <a:schemeClr val="accent1"/>
-          </a:lnRef>
-          <a:fillRef idx="3">
-            <a:schemeClr val="accent1"/>
-          </a:fillRef>
-          <a:effectRef idx="2">
-            <a:schemeClr val="accent1"/>
-          </a:effectRef>
-          <a:fontRef idx="minor">
-            <a:schemeClr val="lt1"/>
-          </a:fontRef>
-        </p:style>
-        <p:txBody>
-          <a:bodyPr rtlCol="0" anchor="ctr"/>
-          <a:lstStyle/>
-          <a:p>
-            <a:pPr algn="ctr"/>
-          </a:p>
-        </p:txBody>
-      </p:sp>
-      <mc:AlternateContent xmlns:mc="http://schemas.openxmlformats.org/markup-compatibility/2006">
-        <mc:Choice xmlns:a14="http://schemas.microsoft.com/office/drawing/2010/main" Requires="a14">
-          <p:sp>
-            <p:nvSpPr>
-              <p:cNvPr id="11" name="s2_chu"/>
-              <p:cNvSpPr txBox="1"/>
-              <p:nvPr/>
-            </p:nvSpPr>
-            <p:spPr>
-              <a:xfrm>
-                <a:off x="713232" y="3831335"/>
+                <a:off x="713232" y="3950207"/>
                 <a:ext cx="10735056" cy="771143"/>
               </a:xfrm>
               <a:prstGeom prst="rect">
@@ -29661,13 +30035,13 @@
         <mc:Fallback>
           <p:sp>
             <p:nvSpPr>
-              <p:cNvPr id="11" name="TextBox 10"/>
+              <p:cNvPr id="12" name="TextBox 11"/>
               <p:cNvSpPr txBox="1"/>
               <p:nvPr/>
             </p:nvSpPr>
             <p:spPr>
               <a:xfrm>
-                <a:off x="713232" y="3831335"/>
+                <a:off x="713232" y="3950207"/>
                 <a:ext cx="10735056" cy="771143"/>
               </a:xfrm>
               <a:prstGeom prst="rect">
@@ -30002,21 +30376,66 @@
                                   </p:childTnLst>
                                 </p:cTn>
                               </p:par>
+                            </p:childTnLst>
+                          </p:cTn>
+                        </p:par>
+                      </p:childTnLst>
+                    </p:cTn>
+                  </p:par>
+                  <p:par>
+                    <p:cTn id="13" fill="hold">
+                      <p:stCondLst>
+                        <p:cond delay="indefinite"/>
+                      </p:stCondLst>
+                      <p:childTnLst>
+                        <p:par>
+                          <p:cTn id="14" fill="hold">
+                            <p:stCondLst>
+                              <p:cond delay="0"/>
+                            </p:stCondLst>
+                            <p:childTnLst>
                               <p:par>
-                                <p:cTn id="13" presetID="1" presetClass="entr" presetSubtype="0" fill="hold" nodeType="withEffect">
+                                <p:cTn id="15" presetID="1" presetClass="entr" presetSubtype="0" fill="hold" nodeType="clickEffect">
                                   <p:stCondLst>
                                     <p:cond delay="0"/>
                                   </p:stCondLst>
                                   <p:childTnLst>
                                     <p:set>
                                       <p:cBhvr>
-                                        <p:cTn id="14" dur="1" fill="hold">
+                                        <p:cTn id="16" dur="1" fill="hold">
                                           <p:stCondLst>
                                             <p:cond delay="0"/>
                                           </p:stCondLst>
                                         </p:cTn>
                                         <p:tgtEl>
                                           <p:spTgt spid="11"/>
+                                        </p:tgtEl>
+                                        <p:attrNameLst>
+                                          <p:attrName>style.visibility</p:attrName>
+                                        </p:attrNameLst>
+                                      </p:cBhvr>
+                                      <p:to>
+                                        <p:strVal val="visible"/>
+                                      </p:to>
+                                    </p:set>
+                                  </p:childTnLst>
+                                </p:cTn>
+                              </p:par>
+                              <p:par>
+                                <p:cTn id="17" presetID="1" presetClass="entr" presetSubtype="0" fill="hold" nodeType="withEffect">
+                                  <p:stCondLst>
+                                    <p:cond delay="0"/>
+                                  </p:stCondLst>
+                                  <p:childTnLst>
+                                    <p:set>
+                                      <p:cBhvr>
+                                        <p:cTn id="18" dur="1" fill="hold">
+                                          <p:stCondLst>
+                                            <p:cond delay="0"/>
+                                          </p:stCondLst>
+                                        </p:cTn>
+                                        <p:tgtEl>
+                                          <p:spTgt spid="12"/>
                                         </p:tgtEl>
                                         <p:attrNameLst>
                                           <p:attrName>style.visibility</p:attrName>
@@ -30852,7 +31271,7 @@
         </p:nvSpPr>
         <p:spPr>
           <a:xfrm>
-            <a:off x="548640" y="3084576"/>
+            <a:off x="548640" y="3057144"/>
             <a:ext cx="8138160" cy="844295"/>
           </a:xfrm>
           <a:prstGeom prst="roundRect">
@@ -30902,7 +31321,7 @@
             </p:nvSpPr>
             <p:spPr>
               <a:xfrm>
-                <a:off x="713232" y="3121152"/>
+                <a:off x="713232" y="3093720"/>
                 <a:ext cx="7808976" cy="771143"/>
               </a:xfrm>
               <a:prstGeom prst="rect">
@@ -31113,7 +31532,7 @@
             </p:nvSpPr>
             <p:spPr>
               <a:xfrm>
-                <a:off x="713232" y="3121152"/>
+                <a:off x="713232" y="3093720"/>
                 <a:ext cx="7808976" cy="771143"/>
               </a:xfrm>
               <a:prstGeom prst="rect">
@@ -31206,7 +31625,7 @@
         </p:nvSpPr>
         <p:spPr>
           <a:xfrm>
-            <a:off x="548640" y="3983736"/>
+            <a:off x="548640" y="3965448"/>
             <a:ext cx="8138160" cy="554735"/>
           </a:xfrm>
           <a:prstGeom prst="roundRect">
@@ -31256,7 +31675,7 @@
             </p:nvSpPr>
             <p:spPr>
               <a:xfrm>
-                <a:off x="713232" y="4020312"/>
+                <a:off x="713232" y="4002024"/>
                 <a:ext cx="7808976" cy="481583"/>
               </a:xfrm>
               <a:prstGeom prst="rect">
@@ -31319,7 +31738,7 @@
             </p:nvSpPr>
             <p:spPr>
               <a:xfrm>
-                <a:off x="713232" y="4020312"/>
+                <a:off x="713232" y="4002024"/>
                 <a:ext cx="7808976" cy="481583"/>
               </a:xfrm>
               <a:prstGeom prst="rect">
@@ -37995,7 +38414,7 @@
         <mc:Choice xmlns:a14="http://schemas.microsoft.com/office/drawing/2010/main" Requires="a14">
           <p:sp>
             <p:nvSpPr>
-              <p:cNvPr id="10" name="TextBox 9"/>
+              <p:cNvPr id="10" name="s2_chu"/>
               <p:cNvSpPr txBox="1"/>
               <p:nvPr/>
             </p:nvSpPr>
@@ -38235,7 +38654,7 @@
       </mc:AlternateContent>
       <p:sp>
         <p:nvSpPr>
-          <p:cNvPr id="11" name="s2_nen"/>
+          <p:cNvPr id="11" name="s3_nen"/>
           <p:cNvSpPr/>
           <p:nvPr/>
         </p:nvSpPr>
@@ -38285,7 +38704,7 @@
         <mc:Choice xmlns:a14="http://schemas.microsoft.com/office/drawing/2010/main" Requires="a14">
           <p:sp>
             <p:nvSpPr>
-              <p:cNvPr id="12" name="s2_chu"/>
+              <p:cNvPr id="12" name="s3_chu"/>
               <p:cNvSpPr txBox="1"/>
               <p:nvPr/>
             </p:nvSpPr>
@@ -38728,6 +39147,51 @@
                                           </p:stCondLst>
                                         </p:cTn>
                                         <p:tgtEl>
+                                          <p:spTgt spid="10"/>
+                                        </p:tgtEl>
+                                        <p:attrNameLst>
+                                          <p:attrName>style.visibility</p:attrName>
+                                        </p:attrNameLst>
+                                      </p:cBhvr>
+                                      <p:to>
+                                        <p:strVal val="visible"/>
+                                      </p:to>
+                                    </p:set>
+                                  </p:childTnLst>
+                                </p:cTn>
+                              </p:par>
+                            </p:childTnLst>
+                          </p:cTn>
+                        </p:par>
+                      </p:childTnLst>
+                    </p:cTn>
+                  </p:par>
+                  <p:par>
+                    <p:cTn id="13" fill="hold">
+                      <p:stCondLst>
+                        <p:cond delay="indefinite"/>
+                      </p:stCondLst>
+                      <p:childTnLst>
+                        <p:par>
+                          <p:cTn id="14" fill="hold">
+                            <p:stCondLst>
+                              <p:cond delay="0"/>
+                            </p:stCondLst>
+                            <p:childTnLst>
+                              <p:par>
+                                <p:cTn id="15" presetID="1" presetClass="entr" presetSubtype="0" fill="hold" nodeType="clickEffect">
+                                  <p:stCondLst>
+                                    <p:cond delay="0"/>
+                                  </p:stCondLst>
+                                  <p:childTnLst>
+                                    <p:set>
+                                      <p:cBhvr>
+                                        <p:cTn id="16" dur="1" fill="hold">
+                                          <p:stCondLst>
+                                            <p:cond delay="0"/>
+                                          </p:stCondLst>
+                                        </p:cTn>
+                                        <p:tgtEl>
                                           <p:spTgt spid="11"/>
                                         </p:tgtEl>
                                         <p:attrNameLst>
@@ -38742,14 +39206,14 @@
                                 </p:cTn>
                               </p:par>
                               <p:par>
-                                <p:cTn id="13" presetID="1" presetClass="entr" presetSubtype="0" fill="hold" nodeType="withEffect">
+                                <p:cTn id="17" presetID="1" presetClass="entr" presetSubtype="0" fill="hold" nodeType="withEffect">
                                   <p:stCondLst>
                                     <p:cond delay="0"/>
                                   </p:stCondLst>
                                   <p:childTnLst>
                                     <p:set>
                                       <p:cBhvr>
-                                        <p:cTn id="14" dur="1" fill="hold">
+                                        <p:cTn id="18" dur="1" fill="hold">
                                           <p:stCondLst>
                                             <p:cond delay="0"/>
                                           </p:stCondLst>
@@ -39077,7 +39541,7 @@
       </p:sp>
       <p:sp>
         <p:nvSpPr>
-          <p:cNvPr id="8" name="TextBox 7"/>
+          <p:cNvPr id="8" name="s1_chu"/>
           <p:cNvSpPr txBox="1"/>
           <p:nvPr/>
         </p:nvSpPr>
@@ -39148,7 +39612,7 @@
       </p:sp>
       <p:sp>
         <p:nvSpPr>
-          <p:cNvPr id="9" name="s1_nen"/>
+          <p:cNvPr id="9" name="s2_nen"/>
           <p:cNvSpPr/>
           <p:nvPr/>
         </p:nvSpPr>
@@ -39196,7 +39660,7 @@
       </p:sp>
       <p:sp>
         <p:nvSpPr>
-          <p:cNvPr id="10" name="s1_chu"/>
+          <p:cNvPr id="10" name="s2_chu"/>
           <p:cNvSpPr txBox="1"/>
           <p:nvPr/>
         </p:nvSpPr>
@@ -39335,6 +39799,51 @@
                                           </p:stCondLst>
                                         </p:cTn>
                                         <p:tgtEl>
+                                          <p:spTgt spid="8"/>
+                                        </p:tgtEl>
+                                        <p:attrNameLst>
+                                          <p:attrName>style.visibility</p:attrName>
+                                        </p:attrNameLst>
+                                      </p:cBhvr>
+                                      <p:to>
+                                        <p:strVal val="visible"/>
+                                      </p:to>
+                                    </p:set>
+                                  </p:childTnLst>
+                                </p:cTn>
+                              </p:par>
+                            </p:childTnLst>
+                          </p:cTn>
+                        </p:par>
+                      </p:childTnLst>
+                    </p:cTn>
+                  </p:par>
+                  <p:par>
+                    <p:cTn id="7" fill="hold">
+                      <p:stCondLst>
+                        <p:cond delay="indefinite"/>
+                      </p:stCondLst>
+                      <p:childTnLst>
+                        <p:par>
+                          <p:cTn id="8" fill="hold">
+                            <p:stCondLst>
+                              <p:cond delay="0"/>
+                            </p:stCondLst>
+                            <p:childTnLst>
+                              <p:par>
+                                <p:cTn id="9" presetID="1" presetClass="entr" presetSubtype="0" fill="hold" nodeType="clickEffect">
+                                  <p:stCondLst>
+                                    <p:cond delay="0"/>
+                                  </p:stCondLst>
+                                  <p:childTnLst>
+                                    <p:set>
+                                      <p:cBhvr>
+                                        <p:cTn id="10" dur="1" fill="hold">
+                                          <p:stCondLst>
+                                            <p:cond delay="0"/>
+                                          </p:stCondLst>
+                                        </p:cTn>
+                                        <p:tgtEl>
                                           <p:spTgt spid="9"/>
                                         </p:tgtEl>
                                         <p:attrNameLst>
@@ -39349,14 +39858,14 @@
                                 </p:cTn>
                               </p:par>
                               <p:par>
-                                <p:cTn id="7" presetID="1" presetClass="entr" presetSubtype="0" fill="hold" nodeType="withEffect">
+                                <p:cTn id="11" presetID="1" presetClass="entr" presetSubtype="0" fill="hold" nodeType="withEffect">
                                   <p:stCondLst>
                                     <p:cond delay="0"/>
                                   </p:stCondLst>
                                   <p:childTnLst>
                                     <p:set>
                                       <p:cBhvr>
-                                        <p:cTn id="8" dur="1" fill="hold">
+                                        <p:cTn id="12" dur="1" fill="hold">
                                           <p:stCondLst>
                                             <p:cond delay="0"/>
                                           </p:stCondLst>

</xml_diff>